<commit_message>
Actualizar demo y entrega de Umbral y retirar archivos LFS
</commit_message>
<xml_diff>
--- a/02_Prediccion_y_escenarios_de_riesgo/entrega/presentacion/Umbral_presentacion.pptx
+++ b/02_Prediccion_y_escenarios_de_riesgo/entrega/presentacion/Umbral_presentacion.pptx
@@ -1071,7 +1071,7 @@
           <a:lstStyle/>
           <a:p>
             <a:r>
-              <a:t>Dos métodos × NS 5/10/20: frecuencia topN y concordancia describen estabilidad. No expresan confianza calibrada.</a:t>
+              <a:t>Frecuencia descriptiva, no probabilidad de acierto. La frontera orienta revisión y propuesta de piloto.</a:t>
             </a:r>
           </a:p>
           <a:p>
@@ -1151,7 +1151,7 @@
           <a:lstStyle/>
           <a:p>
             <a:r>
-              <a:t>La proximidad del score no demuestra equivalencia. El prototipo no acredita impacto causal ni un diseño RDD.</a:t>
+              <a:t>Configuración nacional: catálogo constante, tasa, Ridge, 50 municipios, estabilidad Todas. Base SV+NV 2024: 255,362.</a:t>
             </a:r>
           </a:p>
           <a:p>
@@ -1231,7 +1231,7 @@
           <a:lstStyle/>
           <a:p>
             <a:r>
-              <a:t>Límites: pocas ocasiones electorales, cohortes filtradas y armonización territorial pendiente.</a:t>
+              <a:t>Caso completo: entrega/CASO_MUNICIPAL.md. Guion y demo de tres pasos: entrega/GUION_PRESENTACION.md.</a:t>
             </a:r>
           </a:p>
           <a:p>
@@ -4394,7 +4394,7 @@
               </a:defRPr>
             </a:pPr>
             <a:r>
-              <a:t>Predicción exploratoria y escenarios de abstención para 2027</a:t>
+              <a:t>Revisión territorial con evidencia, capacidad y supuestos visibles</a:t>
             </a:r>
           </a:p>
         </p:txBody>
@@ -4502,7 +4502,7 @@
               </a:defRPr>
             </a:pPr>
             <a:r>
-              <a:t>Versión técnica · 5 de octubre de 2026</a:t>
+              <a:t>Versión técnica · 6 de octubre de 2026</a:t>
             </a:r>
           </a:p>
         </p:txBody>
@@ -6759,7 +6759,7 @@
         <p:spPr>
           <a:xfrm>
             <a:off x="594360" y="2331720"/>
-            <a:ext cx="5349240" cy="3378467"/>
+            <a:ext cx="5349240" cy="3248125"/>
           </a:xfrm>
           <a:prstGeom prst="rect">
             <a:avLst/>
@@ -6783,7 +6783,7 @@
         <p:spPr>
           <a:xfrm>
             <a:off x="6263640" y="2331720"/>
-            <a:ext cx="5349240" cy="3378467"/>
+            <a:ext cx="5349240" cy="3248125"/>
           </a:xfrm>
           <a:prstGeom prst="rect">
             <a:avLst/>
@@ -6955,7 +6955,7 @@
               </a:defRPr>
             </a:pPr>
             <a:r>
-              <a:t>La prioridad depende del objetivo</a:t>
+              <a:t>Una ficha para revisar cada prioridad</a:t>
             </a:r>
           </a:p>
         </p:txBody>
@@ -6983,7 +6983,7 @@
           <a:lstStyle/>
           <a:p>
             <a:pPr>
-              <a:defRPr sz="2400" b="1">
+              <a:defRPr sz="2600" b="1">
                 <a:solidFill>
                   <a:srgbClr val="10685F"/>
                 </a:solidFill>
@@ -6991,7 +6991,7 @@
               </a:defRPr>
             </a:pPr>
             <a:r>
-              <a:t>Tasa</a:t>
+              <a:t>¿Por qué este municipio?</a:t>
             </a:r>
           </a:p>
         </p:txBody>
@@ -7004,7 +7004,7 @@
         </p:nvSpPr>
         <p:spPr>
           <a:xfrm>
-            <a:off x="594360" y="2538983"/>
+            <a:off x="594360" y="2569971"/>
             <a:ext cx="10881360" cy="914400"/>
           </a:xfrm>
           <a:prstGeom prst="rect">
@@ -7027,7 +7027,7 @@
               </a:defRPr>
             </a:pPr>
             <a:r>
-              <a:t>Revisa municipios con mayor abstención estimada.</a:t>
+              <a:t>Puesto, antecedentes, calidad NS y acuerdo entre referencia y Ridge. Perfil CCPC por grupos como capa descriptiva separada.</a:t>
             </a:r>
           </a:p>
         </p:txBody>
@@ -7040,7 +7040,7 @@
         </p:nvSpPr>
         <p:spPr>
           <a:xfrm>
-            <a:off x="594360" y="3065525"/>
+            <a:off x="594360" y="3421887"/>
             <a:ext cx="10881360" cy="914400"/>
           </a:xfrm>
           <a:prstGeom prst="rect">
@@ -7055,15 +7055,15 @@
           <a:lstStyle/>
           <a:p>
             <a:pPr>
-              <a:defRPr sz="2400" b="1">
-                <a:solidFill>
-                  <a:srgbClr val="10685F"/>
+              <a:defRPr sz="2200" b="0">
+                <a:solidFill>
+                  <a:srgbClr val="15353B"/>
                 </a:solidFill>
                 <a:latin typeface="Segoe UI"/>
               </a:defRPr>
             </a:pPr>
             <a:r>
-              <a:t>Volumen sobre observados 2024</a:t>
+              <a:t>Estabilidad de selección: dos métodos × NS 5/10/20.</a:t>
             </a:r>
           </a:p>
         </p:txBody>
@@ -7076,7 +7076,7 @@
         </p:nvSpPr>
         <p:spPr>
           <a:xfrm>
-            <a:off x="594360" y="3638549"/>
+            <a:off x="594360" y="3963924"/>
             <a:ext cx="10881360" cy="914400"/>
           </a:xfrm>
           <a:prstGeom prst="rect">
@@ -7099,7 +7099,7 @@
               </a:defRPr>
             </a:pPr>
             <a:r>
-              <a:t>Revisa dónde la tasa implica más abstenciones en la base observable.</a:t>
+              <a:t>6/6: núcleo robusto; 1/6–5/6: zona de revisión. Elegibilidad aparte. Las variantes comparten datos y pueden equivocarse juntas.</a:t>
             </a:r>
           </a:p>
         </p:txBody>
@@ -7112,8 +7112,8 @@
         </p:nvSpPr>
         <p:spPr>
           <a:xfrm>
-            <a:off x="594360" y="4165091"/>
-            <a:ext cx="10881360" cy="914400"/>
+            <a:off x="594360" y="6245352"/>
+            <a:ext cx="10881360" cy="411480"/>
           </a:xfrm>
           <a:prstGeom prst="rect">
             <a:avLst/>
@@ -7127,87 +7127,15 @@
           <a:lstStyle/>
           <a:p>
             <a:pPr>
-              <a:defRPr sz="2400" b="1">
-                <a:solidFill>
-                  <a:srgbClr val="10685F"/>
+              <a:defRPr sz="1000" b="0">
+                <a:solidFill>
+                  <a:srgbClr val="587177"/>
                 </a:solidFill>
                 <a:latin typeface="Segoe UI"/>
               </a:defRPr>
             </a:pPr>
             <a:r>
-              <a:t>Deterioro respecto al mismo tipo electoral</a:t>
-            </a:r>
-          </a:p>
-        </p:txBody>
-      </p:sp>
-      <p:sp>
-        <p:nvSpPr>
-          <p:cNvPr id="9" name="TextBox 8"/>
-          <p:cNvSpPr txBox="1"/>
-          <p:nvPr/>
-        </p:nvSpPr>
-        <p:spPr>
-          <a:xfrm>
-            <a:off x="594360" y="4738116"/>
-            <a:ext cx="10881360" cy="914400"/>
-          </a:xfrm>
-          <a:prstGeom prst="rect">
-            <a:avLst/>
-          </a:prstGeom>
-          <a:noFill/>
-        </p:spPr>
-        <p:txBody>
-          <a:bodyPr wrap="square" lIns="0" rIns="0" tIns="0" bIns="0">
-            <a:spAutoFit/>
-          </a:bodyPr>
-          <a:lstStyle/>
-          <a:p>
-            <a:pPr>
-              <a:defRPr sz="2100" b="0">
-                <a:solidFill>
-                  <a:srgbClr val="15353B"/>
-                </a:solidFill>
-                <a:latin typeface="Segoe UI"/>
-              </a:defRPr>
-            </a:pPr>
-            <a:r>
-              <a:t>Revisa el aumento estimado frente al antecedente comparable.</a:t>
-            </a:r>
-          </a:p>
-        </p:txBody>
-      </p:sp>
-      <p:sp>
-        <p:nvSpPr>
-          <p:cNvPr id="10" name="TextBox 9"/>
-          <p:cNvSpPr txBox="1"/>
-          <p:nvPr/>
-        </p:nvSpPr>
-        <p:spPr>
-          <a:xfrm>
-            <a:off x="594360" y="6245352"/>
-            <a:ext cx="10881360" cy="411480"/>
-          </a:xfrm>
-          <a:prstGeom prst="rect">
-            <a:avLst/>
-          </a:prstGeom>
-          <a:noFill/>
-        </p:spPr>
-        <p:txBody>
-          <a:bodyPr wrap="square" lIns="0" rIns="0" tIns="0" bIns="0">
-            <a:spAutoFit/>
-          </a:bodyPr>
-          <a:lstStyle/>
-          <a:p>
-            <a:pPr>
-              <a:defRPr sz="1000" b="0">
-                <a:solidFill>
-                  <a:srgbClr val="587177"/>
-                </a:solidFill>
-                <a:latin typeface="Segoe UI"/>
-              </a:defRPr>
-            </a:pPr>
-            <a:r>
-              <a:t>Dos métodos × NS 5/10/20: frecuencia topN y concordancia describen estabilidad. No expresan confianza calibrada.</a:t>
+              <a:t>Frecuencia descriptiva, no probabilidad de acierto. La frontera orienta revisión y propuesta de piloto.</a:t>
             </a:r>
           </a:p>
         </p:txBody>
@@ -7305,7 +7233,7 @@
               </a:defRPr>
             </a:pPr>
             <a:r>
-              <a:t>Prevención con una ficha verificable</a:t>
+              <a:t>Caso 23008: prioridad que requiere revisión</a:t>
             </a:r>
           </a:p>
         </p:txBody>
@@ -7333,7 +7261,7 @@
           <a:lstStyle/>
           <a:p>
             <a:pPr>
-              <a:defRPr sz="2600" b="1">
+              <a:defRPr sz="2400" b="1">
                 <a:solidFill>
                   <a:srgbClr val="10685F"/>
                 </a:solidFill>
@@ -7341,7 +7269,7 @@
               </a:defRPr>
             </a:pPr>
             <a:r>
-              <a:t>Cada municipio necesita una propuesta revisable</a:t>
+              <a:t>SOLIDARIDAD · catálogo histórico de Quintana Roo</a:t>
             </a:r>
           </a:p>
         </p:txBody>
@@ -7354,7 +7282,7 @@
         </p:nvSpPr>
         <p:spPr>
           <a:xfrm>
-            <a:off x="594360" y="2569971"/>
+            <a:off x="594360" y="2538983"/>
             <a:ext cx="10881360" cy="914400"/>
           </a:xfrm>
           <a:prstGeom prst="rect">
@@ -7369,7 +7297,7 @@
           <a:lstStyle/>
           <a:p>
             <a:pPr>
-              <a:defRPr sz="2200" b="0">
+              <a:defRPr sz="2100" b="0">
                 <a:solidFill>
                   <a:srgbClr val="15353B"/>
                 </a:solidFill>
@@ -7377,7 +7305,7 @@
               </a:defRPr>
             </a:pPr>
             <a:r>
-              <a:t>La ficha relaciona antecedentes observables con una acción de información electoral accesible o educación cívica.</a:t>
+              <a:t>Puesto Ridge 1; referencia 3. Estimación exploratoria 62.11%. Estabilidad 4/6: NS 2021 de 9.60% excluye variantes NS ≤5%.</a:t>
             </a:r>
           </a:p>
         </p:txBody>
@@ -7390,7 +7318,7 @@
         </p:nvSpPr>
         <p:spPr>
           <a:xfrm>
-            <a:off x="594360" y="3452875"/>
+            <a:off x="594360" y="3390899"/>
             <a:ext cx="10881360" cy="914400"/>
           </a:xfrm>
           <a:prstGeom prst="rect">
@@ -7405,7 +7333,7 @@
           <a:lstStyle/>
           <a:p>
             <a:pPr>
-              <a:defRPr sz="2200" b="0">
+              <a:defRPr sz="2100" b="0">
                 <a:solidFill>
                   <a:srgbClr val="15353B"/>
                 </a:solidFill>
@@ -7413,7 +7341,7 @@
               </a:defRPr>
             </a:pPr>
             <a:r>
-              <a:t>Registra responsable propuesto, personas alcanzadas, condiciones de aplicación y medición. El mecanismo esperado es una hipótesis.</a:t>
+              <a:t>Acción propuesta: talleres abiertos sobre requisitos y procedimiento. Educación cívica y junta local; sedes y capacidad por validar.</a:t>
             </a:r>
           </a:p>
         </p:txBody>
@@ -7426,7 +7354,7 @@
         </p:nvSpPr>
         <p:spPr>
           <a:xfrm>
-            <a:off x="594360" y="4335780"/>
+            <a:off x="594360" y="4242816"/>
             <a:ext cx="10881360" cy="914400"/>
           </a:xfrm>
           <a:prstGeom prst="rect">
@@ -7441,7 +7369,7 @@
           <a:lstStyle/>
           <a:p>
             <a:pPr>
-              <a:defRPr sz="2000" b="0">
+              <a:defRPr sz="2100" b="0">
                 <a:solidFill>
                   <a:srgbClr val="15353B"/>
                 </a:solidFill>
@@ -7449,7 +7377,7 @@
               </a:defRPr>
             </a:pPr>
             <a:r>
-              <a:t>Piloto propuesto: asignación aleatoria dentro de un conjunto elegible y balanceado alrededor del corte. Medir cobertura y participación.</a:t>
+              <a:t>1,000 alcanzados y respuesta supuesta 25%: 155.27 adicionales hipotéticos; 62.11% → 62.05%. Permanece alto.</a:t>
             </a:r>
           </a:p>
         </p:txBody>
@@ -7485,7 +7413,7 @@
               </a:defRPr>
             </a:pPr>
             <a:r>
-              <a:t>La proximidad del score no demuestra equivalencia. El prototipo no acredita impacto causal ni un diseño RDD.</a:t>
+              <a:t>Configuración nacional: catálogo constante, tasa, Ridge, 50 municipios, estabilidad Todas. Base SV+NV 2024: 255,362.</a:t>
             </a:r>
           </a:p>
         </p:txBody>
@@ -7583,7 +7511,7 @@
               </a:defRPr>
             </a:pPr>
             <a:r>
-              <a:t>Uso institucional con revisión humana</a:t>
+              <a:t>De la ficha a un plan verificable</a:t>
             </a:r>
           </a:p>
         </p:txBody>
@@ -7619,7 +7547,7 @@
               </a:defRPr>
             </a:pPr>
             <a:r>
-              <a:t>La vista por entidad resume capacidad y cobertura</a:t>
+              <a:t>Recursos, condiciones y medición</a:t>
             </a:r>
           </a:p>
         </p:txBody>
@@ -7647,7 +7575,7 @@
           <a:lstStyle/>
           <a:p>
             <a:pPr>
-              <a:defRPr sz="2200" b="0">
+              <a:defRPr sz="2100" b="0">
                 <a:solidFill>
                   <a:srgbClr val="15353B"/>
                 </a:solidFill>
@@ -7655,7 +7583,7 @@
               </a:defRPr>
             </a:pPr>
             <a:r>
-              <a:t>El área usuaria revisa calidad, concordancia de listas y viabilidad del alcance. La exportación conserva los supuestos de cada decisión.</a:t>
+              <a:t>Exportar acción, responsable propuesto, alcance, supuestos y estabilidad. Capacidad por municipios o por personas alcanzables.</a:t>
             </a:r>
           </a:p>
         </p:txBody>
@@ -7668,7 +7596,7 @@
         </p:nvSpPr>
         <p:spPr>
           <a:xfrm>
-            <a:off x="594360" y="3437381"/>
+            <a:off x="594360" y="3406393"/>
             <a:ext cx="10881360" cy="914400"/>
           </a:xfrm>
           <a:prstGeom prst="rect">
@@ -7683,7 +7611,7 @@
           <a:lstStyle/>
           <a:p>
             <a:pPr>
-              <a:defRPr sz="2200" b="0">
+              <a:defRPr sz="2100" b="0">
                 <a:solidFill>
                   <a:srgbClr val="15353B"/>
                 </a:solidFill>
@@ -7691,7 +7619,7 @@
               </a:defRPr>
             </a:pPr>
             <a:r>
-              <a:t>Las claves municipales permiten trazabilidad. Sin correspondencia verificada, el producto no atribuye municipios a distritos.</a:t>
+              <a:t>Registrar alcance único agregado, horas y conocimiento previo/posterior. El perfil joven orienta canales; no demuestra barreras.</a:t>
             </a:r>
           </a:p>
         </p:txBody>
@@ -7704,7 +7632,7 @@
         </p:nvSpPr>
         <p:spPr>
           <a:xfrm>
-            <a:off x="594360" y="4320286"/>
+            <a:off x="594360" y="4258310"/>
             <a:ext cx="10881360" cy="914400"/>
           </a:xfrm>
           <a:prstGeom prst="rect">
@@ -7727,7 +7655,7 @@
               </a:defRPr>
             </a:pPr>
             <a:r>
-              <a:t>La demo local y los datos agregados permiten inspección sin dependencias remotas.</a:t>
+              <a:t>Validar límites, sedes y atribuciones. Un efecto sobre participación requiere evaluación comparativa y protocolo previo.</a:t>
             </a:r>
           </a:p>
         </p:txBody>
@@ -7763,7 +7691,7 @@
               </a:defRPr>
             </a:pPr>
             <a:r>
-              <a:t>Límites: pocas ocasiones electorales, cohortes filtradas y armonización territorial pendiente.</a:t>
+              <a:t>Caso completo: entrega/CASO_MUNICIPAL.md. Guion y demo de tres pasos: entrega/GUION_PRESENTACION.md.</a:t>
             </a:r>
           </a:p>
         </p:txBody>

</xml_diff>

<commit_message>
falta revisa los planes personalizados
</commit_message>
<xml_diff>
--- a/02_Prediccion_y_escenarios_de_riesgo/entrega/presentacion/Umbral_presentacion.pptx
+++ b/02_Prediccion_y_escenarios_de_riesgo/entrega/presentacion/Umbral_presentacion.pptx
@@ -681,7 +681,7 @@
           </a:p>
           <a:p>
             <a:r>
-              <a:t>País: México, municipios con estimación incluidos. Los filtros y exclusiones delimitan el alcance. Fuentes primarias: https://ine.mx/transparencia/datos-abiertos/visualizacion-datos/conteos-censales-participacion/ Convocatoria: https://ine.mx/wp-content/uploads/2026/09/Convocatoria_Hackaton-1.pdf</a:t>
+              <a:t>Guía: demo/DEMO6.md. Cartografía municipal y complemento insular INEGI 2025. Fuentes primarias: https://ine.mx/transparencia/datos-abiertos/visualizacion-datos/conteos-censales-participacion/ Convocatoria: https://ine.mx/wp-content/uploads/2026/09/Convocatoria_Hackaton-1.pdf</a:t>
             </a:r>
           </a:p>
         </p:txBody>
@@ -841,7 +841,7 @@
           </a:p>
           <a:p>
             <a:r>
-              <a:t>Fuente: modelado/METODOLOGIA.md y modelado/salidas/metricas.json. No hay ajuste para mejorar 2024. Fuentes primarias: https://ine.mx/transparencia/datos-abiertos/visualizacion-datos/conteos-censales-participacion/ Convocatoria: https://ine.mx/wp-content/uploads/2026/09/Convocatoria_Hackaton-1.pdf</a:t>
+              <a:t>Fuente: modelado/PROTOCOLO_COMPARACION_4_MODELOS.md y salidas/comparacion_modelos/resultados.json. Fuentes primarias: https://ine.mx/transparencia/datos-abiertos/visualizacion-datos/conteos-censales-participacion/ Convocatoria: https://ine.mx/wp-content/uploads/2026/09/Convocatoria_Hackaton-1.pdf</a:t>
             </a:r>
           </a:p>
         </p:txBody>
@@ -921,7 +921,7 @@
           </a:p>
           <a:p>
             <a:r>
-              <a:t>MAE en puntos porcentuales. Ponderación por SV+NV observado del objetivo. Top50 dentro de cada cohorte evaluable. Fuentes primarias: https://ine.mx/transparencia/datos-abiertos/visualizacion-datos/conteos-censales-participacion/ Convocatoria: https://ine.mx/wp-content/uploads/2026/09/Convocatoria_Hackaton-1.pdf</a:t>
+              <a:t>Media de 2021/2024 con igual peso por elección. Referencia adicional: MAE 8.88 pp. No valida 2027. Fuentes primarias: https://ine.mx/transparencia/datos-abiertos/visualizacion-datos/conteos-censales-participacion/ Convocatoria: https://ine.mx/wp-content/uploads/2026/09/Convocatoria_Hackaton-1.pdf</a:t>
             </a:r>
           </a:p>
         </p:txBody>
@@ -1081,7 +1081,7 @@
           </a:p>
           <a:p>
             <a:r>
-              <a:t>Frecuencia descriptiva. Las variantes comparten datos y pueden equivocarse juntas. Fuentes primarias: https://ine.mx/transparencia/datos-abiertos/visualizacion-datos/conteos-censales-participacion/ Convocatoria: https://ine.mx/wp-content/uploads/2026/09/Convocatoria_Hackaton-1.pdf</a:t>
+              <a:t>Demo6. Umbrales nacionales por año y método; fijos entre escenarios. Fuentes primarias: https://ine.mx/transparencia/datos-abiertos/visualizacion-datos/conteos-censales-participacion/ Convocatoria: https://ine.mx/wp-content/uploads/2026/09/Convocatoria_Hackaton-1.pdf</a:t>
             </a:r>
           </a:p>
         </p:txBody>
@@ -1161,7 +1161,7 @@
           </a:p>
           <a:p>
             <a:r>
-              <a:t>Fuente: entrega/caso_municipal.json. SV+NV 2024: 255,362. SMS: Lindgren, Nyman y Oskarsson (2025), DOI 10.1017/S0007123424000504. Fuentes primarias: https://ine.mx/transparencia/datos-abiertos/visualizacion-datos/conteos-censales-participacion/ Convocatoria: https://ine.mx/wp-content/uploads/2026/09/Convocatoria_Hackaton-1.pdf</a:t>
+              <a:t>Fuente: entrega/caso_municipal.json. Modelo seleccionado del benchmark. SV+NV 2024: 255,362. DOI 10.1017/S0007123424000504. Fuentes primarias: https://ine.mx/transparencia/datos-abiertos/visualizacion-datos/conteos-censales-participacion/ Convocatoria: https://ine.mx/wp-content/uploads/2026/09/Convocatoria_Hackaton-1.pdf</a:t>
             </a:r>
           </a:p>
         </p:txBody>
@@ -4264,7 +4264,7 @@
         <p:spPr>
           <a:xfrm>
             <a:off x="594360" y="320040"/>
-            <a:ext cx="10972800" cy="274320"/>
+            <a:ext cx="10972800" cy="259080"/>
           </a:xfrm>
           <a:prstGeom prst="rect">
             <a:avLst/>
@@ -4298,7 +4298,7 @@
         <p:spPr>
           <a:xfrm>
             <a:off x="594360" y="822960"/>
-            <a:ext cx="10972800" cy="1097280"/>
+            <a:ext cx="10972800" cy="754888"/>
           </a:xfrm>
           <a:prstGeom prst="rect">
             <a:avLst/>
@@ -4332,7 +4332,7 @@
         <p:spPr>
           <a:xfrm>
             <a:off x="594360" y="2377440"/>
-            <a:ext cx="10881360" cy="640080"/>
+            <a:ext cx="10881360" cy="506984"/>
           </a:xfrm>
           <a:prstGeom prst="rect">
             <a:avLst/>
@@ -4366,7 +4366,7 @@
         <p:spPr>
           <a:xfrm>
             <a:off x="594360" y="3012440"/>
-            <a:ext cx="10881360" cy="914400"/>
+            <a:ext cx="10881360" cy="414020"/>
           </a:xfrm>
           <a:prstGeom prst="rect">
             <a:avLst/>
@@ -4400,7 +4400,7 @@
         <p:spPr>
           <a:xfrm>
             <a:off x="594360" y="3554476"/>
-            <a:ext cx="10881360" cy="914400"/>
+            <a:ext cx="10881360" cy="352044"/>
           </a:xfrm>
           <a:prstGeom prst="rect">
             <a:avLst/>
@@ -4434,7 +4434,7 @@
         <p:spPr>
           <a:xfrm>
             <a:off x="594360" y="4034536"/>
-            <a:ext cx="10881360" cy="914400"/>
+            <a:ext cx="10881360" cy="336550"/>
           </a:xfrm>
           <a:prstGeom prst="rect">
             <a:avLst/>
@@ -4468,7 +4468,7 @@
         <p:spPr>
           <a:xfrm>
             <a:off x="594360" y="4499102"/>
-            <a:ext cx="10881360" cy="914400"/>
+            <a:ext cx="10881360" cy="336550"/>
           </a:xfrm>
           <a:prstGeom prst="rect">
             <a:avLst/>
@@ -4488,7 +4488,7 @@
                 </a:solidFill>
                 <a:latin typeface="Segoe UI"/>
               </a:rPr>
-              <a:t>Versión técnica · 6 de octubre de 2026</a:t>
+              <a:t>Versión técnica · 16 de octubre de 2026</a:t>
             </a:r>
           </a:p>
         </p:txBody>
@@ -4502,7 +4502,7 @@
         <p:spPr>
           <a:xfrm>
             <a:off x="594360" y="6245352"/>
-            <a:ext cx="10881360" cy="411480"/>
+            <a:ext cx="10881360" cy="228092"/>
           </a:xfrm>
           <a:prstGeom prst="rect">
             <a:avLst/>
@@ -4562,7 +4562,7 @@
         <p:spPr>
           <a:xfrm>
             <a:off x="594360" y="320040"/>
-            <a:ext cx="10972800" cy="274320"/>
+            <a:ext cx="10972800" cy="259080"/>
           </a:xfrm>
           <a:prstGeom prst="rect">
             <a:avLst/>
@@ -4596,7 +4596,7 @@
         <p:spPr>
           <a:xfrm>
             <a:off x="594360" y="822960"/>
-            <a:ext cx="10972800" cy="1097280"/>
+            <a:ext cx="10972800" cy="568960"/>
           </a:xfrm>
           <a:prstGeom prst="rect">
             <a:avLst/>
@@ -4630,7 +4630,7 @@
         <p:spPr>
           <a:xfrm>
             <a:off x="594360" y="1965960"/>
-            <a:ext cx="10881360" cy="914400"/>
+            <a:ext cx="10881360" cy="475996"/>
           </a:xfrm>
           <a:prstGeom prst="rect">
             <a:avLst/>
@@ -4664,7 +4664,7 @@
         <p:spPr>
           <a:xfrm>
             <a:off x="594360" y="2569972"/>
-            <a:ext cx="10881360" cy="914400"/>
+            <a:ext cx="10881360" cy="754888"/>
           </a:xfrm>
           <a:prstGeom prst="rect">
             <a:avLst/>
@@ -4698,7 +4698,7 @@
         <p:spPr>
           <a:xfrm>
             <a:off x="594360" y="3452876"/>
-            <a:ext cx="10881360" cy="914400"/>
+            <a:ext cx="10881360" cy="475996"/>
           </a:xfrm>
           <a:prstGeom prst="rect">
             <a:avLst/>
@@ -4732,7 +4732,7 @@
         <p:spPr>
           <a:xfrm>
             <a:off x="594360" y="4056888"/>
-            <a:ext cx="10881360" cy="914400"/>
+            <a:ext cx="10881360" cy="754888"/>
           </a:xfrm>
           <a:prstGeom prst="rect">
             <a:avLst/>
@@ -4766,7 +4766,7 @@
         <p:spPr>
           <a:xfrm>
             <a:off x="594360" y="4939792"/>
-            <a:ext cx="10881360" cy="914400"/>
+            <a:ext cx="10881360" cy="367538"/>
           </a:xfrm>
           <a:prstGeom prst="rect">
             <a:avLst/>
@@ -4800,7 +4800,7 @@
         <p:spPr>
           <a:xfrm>
             <a:off x="594360" y="6245352"/>
-            <a:ext cx="10881360" cy="411480"/>
+            <a:ext cx="10881360" cy="228092"/>
           </a:xfrm>
           <a:prstGeom prst="rect">
             <a:avLst/>
@@ -4860,7 +4860,7 @@
         <p:spPr>
           <a:xfrm>
             <a:off x="594360" y="320040"/>
-            <a:ext cx="10972800" cy="274320"/>
+            <a:ext cx="10972800" cy="259080"/>
           </a:xfrm>
           <a:prstGeom prst="rect">
             <a:avLst/>
@@ -4894,7 +4894,7 @@
         <p:spPr>
           <a:xfrm>
             <a:off x="594360" y="822960"/>
-            <a:ext cx="10972800" cy="1097280"/>
+            <a:ext cx="10972800" cy="568960"/>
           </a:xfrm>
           <a:prstGeom prst="rect">
             <a:avLst/>
@@ -4914,7 +4914,7 @@
                 </a:solidFill>
                 <a:latin typeface="Segoe UI"/>
               </a:rPr>
-              <a:t>Territorio y cobertura total</a:t>
+              <a:t>Consulta territorial en demo6</a:t>
             </a:r>
           </a:p>
         </p:txBody>
@@ -4928,7 +4928,7 @@
         <p:spPr>
           <a:xfrm>
             <a:off x="594360" y="1965960"/>
-            <a:ext cx="10881360" cy="914400"/>
+            <a:ext cx="10881360" cy="475996"/>
           </a:xfrm>
           <a:prstGeom prst="rect">
             <a:avLst/>
@@ -4962,7 +4962,7 @@
         <p:spPr>
           <a:xfrm>
             <a:off x="594360" y="2569972"/>
-            <a:ext cx="10881360" cy="914400"/>
+            <a:ext cx="10881360" cy="723900"/>
           </a:xfrm>
           <a:prstGeom prst="rect">
             <a:avLst/>
@@ -4982,7 +4982,7 @@
                 </a:solidFill>
                 <a:latin typeface="Segoe UI"/>
               </a:rPr>
-              <a:t>La persona usuaria elige territorio, acción con evidencia y cobertura total. SMS cuenta personas distintas previstas para envío. Llamada cuenta contactos efectivos.</a:t>
+              <a:t>Un mismo año y método para el mapa, el resumen y la ficha. Los históricos muestran resultados observados y 2027 una proyección diferenciada.</a:t>
             </a:r>
           </a:p>
         </p:txBody>
@@ -4996,7 +4996,7 @@
         <p:spPr>
           <a:xfrm>
             <a:off x="594360" y="3421888"/>
-            <a:ext cx="10881360" cy="914400"/>
+            <a:ext cx="10881360" cy="723900"/>
           </a:xfrm>
           <a:prstGeom prst="rect">
             <a:avLst/>
@@ -5016,7 +5016,7 @@
                 </a:solidFill>
                 <a:latin typeface="Segoe UI"/>
               </a:rPr>
-              <a:t>Prioridad concentra por ranking. Proporcional reparte por SV+NV 2024 entre todos los elegibles, con redondeo por mayor resto y tope de población.</a:t>
+              <a:t>Gráfica temporal y comparación con el promedio estatal, ponderados por personas con dato de voto.</a:t>
             </a:r>
           </a:p>
         </p:txBody>
@@ -5030,7 +5030,7 @@
         <p:spPr>
           <a:xfrm>
             <a:off x="594360" y="4273804"/>
-            <a:ext cx="10881360" cy="914400"/>
+            <a:ext cx="10881360" cy="398526"/>
           </a:xfrm>
           <a:prstGeom prst="rect">
             <a:avLst/>
@@ -5044,13 +5044,13 @@
           <a:lstStyle/>
           <a:p>
             <a:r>
-              <a:rPr sz="1900" b="0">
+              <a:rPr sz="2100" b="0">
                 <a:solidFill>
                   <a:srgbClr val="15353B"/>
                 </a:solidFill>
                 <a:latin typeface="Segoe UI"/>
               </a:rPr>
-              <a:t>Estas reglas son decisiones de planeación propias.</a:t>
+              <a:t>La consulta completa se descarga en CSV, aunque no se configure una intervención.</a:t>
             </a:r>
           </a:p>
         </p:txBody>
@@ -5064,7 +5064,7 @@
         <p:spPr>
           <a:xfrm>
             <a:off x="594360" y="6245352"/>
-            <a:ext cx="10881360" cy="411480"/>
+            <a:ext cx="10881360" cy="228092"/>
           </a:xfrm>
           <a:prstGeom prst="rect">
             <a:avLst/>
@@ -5084,7 +5084,7 @@
                 </a:solidFill>
                 <a:latin typeface="Segoe UI"/>
               </a:rPr>
-              <a:t>País: México, municipios con estimación incluidos. Los filtros y exclusiones delimitan el alcance.</a:t>
+              <a:t>Guía: demo/DEMO6.md. Cartografía municipal y complemento insular INEGI 2025.</a:t>
             </a:r>
           </a:p>
         </p:txBody>
@@ -5124,7 +5124,7 @@
         <p:spPr>
           <a:xfrm>
             <a:off x="594360" y="320040"/>
-            <a:ext cx="10972800" cy="274320"/>
+            <a:ext cx="10972800" cy="259080"/>
           </a:xfrm>
           <a:prstGeom prst="rect">
             <a:avLst/>
@@ -5158,7 +5158,7 @@
         <p:spPr>
           <a:xfrm>
             <a:off x="594360" y="822960"/>
-            <a:ext cx="10972800" cy="1097280"/>
+            <a:ext cx="10972800" cy="568960"/>
           </a:xfrm>
           <a:prstGeom prst="rect">
             <a:avLst/>
@@ -5192,7 +5192,7 @@
         <p:spPr>
           <a:xfrm>
             <a:off x="594360" y="1965960"/>
-            <a:ext cx="10881360" cy="640080"/>
+            <a:ext cx="10881360" cy="630936"/>
           </a:xfrm>
           <a:prstGeom prst="rect">
             <a:avLst/>
@@ -5226,7 +5226,7 @@
         <p:spPr>
           <a:xfrm>
             <a:off x="594360" y="2724912"/>
-            <a:ext cx="10881360" cy="914400"/>
+            <a:ext cx="10881360" cy="445008"/>
           </a:xfrm>
           <a:prstGeom prst="rect">
             <a:avLst/>
@@ -5260,7 +5260,7 @@
         <p:spPr>
           <a:xfrm>
             <a:off x="594360" y="3297936"/>
-            <a:ext cx="10881360" cy="914400"/>
+            <a:ext cx="10881360" cy="445008"/>
           </a:xfrm>
           <a:prstGeom prst="rect">
             <a:avLst/>
@@ -5294,7 +5294,7 @@
         <p:spPr>
           <a:xfrm>
             <a:off x="594360" y="3870960"/>
-            <a:ext cx="10881360" cy="914400"/>
+            <a:ext cx="10881360" cy="692912"/>
           </a:xfrm>
           <a:prstGeom prst="rect">
             <a:avLst/>
@@ -5328,7 +5328,7 @@
         <p:spPr>
           <a:xfrm>
             <a:off x="594360" y="4691888"/>
-            <a:ext cx="10881360" cy="914400"/>
+            <a:ext cx="10881360" cy="692912"/>
           </a:xfrm>
           <a:prstGeom prst="rect">
             <a:avLst/>
@@ -5362,7 +5362,7 @@
         <p:spPr>
           <a:xfrm>
             <a:off x="594360" y="6245352"/>
-            <a:ext cx="10881360" cy="411480"/>
+            <a:ext cx="10881360" cy="228092"/>
           </a:xfrm>
           <a:prstGeom prst="rect">
             <a:avLst/>
@@ -5422,7 +5422,7 @@
         <p:spPr>
           <a:xfrm>
             <a:off x="594360" y="320040"/>
-            <a:ext cx="10972800" cy="274320"/>
+            <a:ext cx="10972800" cy="259080"/>
           </a:xfrm>
           <a:prstGeom prst="rect">
             <a:avLst/>
@@ -5456,7 +5456,7 @@
         <p:spPr>
           <a:xfrm>
             <a:off x="594360" y="822960"/>
-            <a:ext cx="10972800" cy="1097280"/>
+            <a:ext cx="10972800" cy="568960"/>
           </a:xfrm>
           <a:prstGeom prst="rect">
             <a:avLst/>
@@ -5476,7 +5476,7 @@
                 </a:solidFill>
                 <a:latin typeface="Segoe UI"/>
               </a:rPr>
-              <a:t>La referencia también compite</a:t>
+              <a:t>Cuatro modelos, una comparación temporal</a:t>
             </a:r>
           </a:p>
         </p:txBody>
@@ -5490,7 +5490,7 @@
         <p:spPr>
           <a:xfrm>
             <a:off x="594360" y="1965960"/>
-            <a:ext cx="10881360" cy="914400"/>
+            <a:ext cx="10881360" cy="460502"/>
           </a:xfrm>
           <a:prstGeom prst="rect">
             <a:avLst/>
@@ -5504,13 +5504,13 @@
           <a:lstStyle/>
           <a:p>
             <a:r>
-              <a:rPr sz="2400" b="1">
+              <a:rPr sz="2500" b="1">
                 <a:solidFill>
                   <a:srgbClr val="10685F"/>
                 </a:solidFill>
                 <a:latin typeface="Segoe UI"/>
               </a:rPr>
-              <a:t>Referencia: última elección del mismo tipo</a:t>
+              <a:t>Misma cohorte y 15 variables históricas</a:t>
             </a:r>
           </a:p>
         </p:txBody>
@@ -5523,8 +5523,8 @@
         </p:nvSpPr>
         <p:spPr>
           <a:xfrm>
-            <a:off x="594360" y="2538984"/>
-            <a:ext cx="10881360" cy="914400"/>
+            <a:off x="594360" y="2554478"/>
+            <a:ext cx="10881360" cy="723900"/>
           </a:xfrm>
           <a:prstGeom prst="rect">
             <a:avLst/>
@@ -5538,13 +5538,13 @@
           <a:lstStyle/>
           <a:p>
             <a:r>
-              <a:rPr sz="2200" b="0">
+              <a:rPr sz="2100" b="0">
                 <a:solidFill>
                   <a:srgbClr val="15353B"/>
                 </a:solidFill>
                 <a:latin typeface="Segoe UI"/>
               </a:rPr>
-              <a:t>Para 2027 usa 2021. Ridge estima un ajuste con historia electoral, edad agregada, urbanización y calidad.</a:t>
+              <a:t>Ridge, HistGradientBoosting, LightGBM y CatBoost aprenden el residual respecto a la referencia homóloga.</a:t>
             </a:r>
           </a:p>
         </p:txBody>
@@ -5557,8 +5557,8 @@
         </p:nvSpPr>
         <p:spPr>
           <a:xfrm>
-            <a:off x="594360" y="3421888"/>
-            <a:ext cx="10881360" cy="914400"/>
+            <a:off x="594360" y="3406394"/>
+            <a:ext cx="10881360" cy="723900"/>
           </a:xfrm>
           <a:prstGeom prst="rect">
             <a:avLst/>
@@ -5572,13 +5572,13 @@
           <a:lstStyle/>
           <a:p>
             <a:r>
-              <a:rPr sz="2200" b="0">
+              <a:rPr sz="2100" b="0">
                 <a:solidFill>
                   <a:srgbClr val="15353B"/>
                 </a:solidFill>
                 <a:latin typeface="Segoe UI"/>
               </a:rPr>
-              <a:t>Alpha = 10 permanece congelado. Cada corte aprende con resultados anteriores al año objetivo.</a:t>
+              <a:t>Los parámetros se eligen con años anteriores al corte evaluado. Sin parada temprana sobre 2021 o 2024.</a:t>
             </a:r>
           </a:p>
         </p:txBody>
@@ -5591,8 +5591,8 @@
         </p:nvSpPr>
         <p:spPr>
           <a:xfrm>
-            <a:off x="594360" y="4304792"/>
-            <a:ext cx="10881360" cy="914400"/>
+            <a:off x="594360" y="4258310"/>
+            <a:ext cx="10881360" cy="398526"/>
           </a:xfrm>
           <a:prstGeom prst="rect">
             <a:avLst/>
@@ -5606,13 +5606,13 @@
           <a:lstStyle/>
           <a:p>
             <a:r>
-              <a:rPr sz="2000" b="0">
+              <a:rPr sz="2100" b="0">
                 <a:solidFill>
                   <a:srgbClr val="15353B"/>
                 </a:solidFill>
                 <a:latin typeface="Segoe UI"/>
               </a:rPr>
-              <a:t>2021 seleccionó el método. Ese corte no es una prueba independiente posterior a la selección.</a:t>
+              <a:t>Protocolo previo, cuatro configuraciones por familia, semilla 42 y un hilo de CPU.</a:t>
             </a:r>
           </a:p>
         </p:txBody>
@@ -5626,7 +5626,7 @@
         <p:spPr>
           <a:xfrm>
             <a:off x="594360" y="6245352"/>
-            <a:ext cx="10881360" cy="411480"/>
+            <a:ext cx="10881360" cy="228092"/>
           </a:xfrm>
           <a:prstGeom prst="rect">
             <a:avLst/>
@@ -5646,7 +5646,7 @@
                 </a:solidFill>
                 <a:latin typeface="Segoe UI"/>
               </a:rPr>
-              <a:t>Fuente: modelado/METODOLOGIA.md y modelado/salidas/metricas.json. No hay ajuste para mejorar 2024.</a:t>
+              <a:t>Fuente: modelado/PROTOCOLO_COMPARACION_4_MODELOS.md y salidas/comparacion_modelos/resultados.json.</a:t>
             </a:r>
           </a:p>
         </p:txBody>
@@ -5686,7 +5686,7 @@
         <p:spPr>
           <a:xfrm>
             <a:off x="594360" y="320040"/>
-            <a:ext cx="10972800" cy="274320"/>
+            <a:ext cx="10972800" cy="259080"/>
           </a:xfrm>
           <a:prstGeom prst="rect">
             <a:avLst/>
@@ -5720,7 +5720,7 @@
         <p:spPr>
           <a:xfrm>
             <a:off x="594360" y="822960"/>
-            <a:ext cx="10972800" cy="1097280"/>
+            <a:ext cx="10972800" cy="568960"/>
           </a:xfrm>
           <a:prstGeom prst="rect">
             <a:avLst/>
@@ -5740,7 +5740,7 @@
                 </a:solidFill>
                 <a:latin typeface="Segoe UI"/>
               </a:rPr>
-              <a:t>Ridge mejora en 2021 y empeora en 2024</a:t>
+              <a:t>HistGradientBoosting seleccionado</a:t>
             </a:r>
           </a:p>
         </p:txBody>
@@ -5785,7 +5785,7 @@
                         </a:defRPr>
                       </a:pPr>
                       <a:r>
-                        <a:t>Corte / método</a:t>
+                        <a:t>Modelo</a:t>
                       </a:r>
                     </a:p>
                   </a:txBody>
@@ -5809,31 +5809,7 @@
                         </a:defRPr>
                       </a:pPr>
                       <a:r>
-                        <a:t>n</a:t>
-                      </a:r>
-                    </a:p>
-                  </a:txBody>
-                  <a:tcPr>
-                    <a:solidFill>
-                      <a:srgbClr val="E5EEEA"/>
-                    </a:solidFill>
-                  </a:tcPr>
-                </a:tc>
-                <a:tc>
-                  <a:txBody>
-                    <a:bodyPr/>
-                    <a:lstStyle/>
-                    <a:p>
-                      <a:pPr>
-                        <a:defRPr sz="2000" b="1">
-                          <a:solidFill>
-                            <a:srgbClr val="15353B"/>
-                          </a:solidFill>
-                          <a:latin typeface="Segoe UI"/>
-                        </a:defRPr>
-                      </a:pPr>
-                      <a:r>
-                        <a:t>MAE (pp)</a:t>
+                        <a:t>MAE medio</a:t>
                       </a:r>
                     </a:p>
                   </a:txBody>
@@ -5881,7 +5857,31 @@
                         </a:defRPr>
                       </a:pPr>
                       <a:r>
-                        <a:t>Top50</a:t>
+                        <a:t>Top50 medio</a:t>
+                      </a:r>
+                    </a:p>
+                  </a:txBody>
+                  <a:tcPr>
+                    <a:solidFill>
+                      <a:srgbClr val="E5EEEA"/>
+                    </a:solidFill>
+                  </a:tcPr>
+                </a:tc>
+                <a:tc>
+                  <a:txBody>
+                    <a:bodyPr/>
+                    <a:lstStyle/>
+                    <a:p>
+                      <a:pPr>
+                        <a:defRPr sz="2000" b="1">
+                          <a:solidFill>
+                            <a:srgbClr val="15353B"/>
+                          </a:solidFill>
+                          <a:latin typeface="Segoe UI"/>
+                        </a:defRPr>
+                      </a:pPr>
+                      <a:r>
+                        <a:t>Ajustar ms</a:t>
                       </a:r>
                     </a:p>
                   </a:txBody>
@@ -5907,7 +5907,7 @@
                         </a:defRPr>
                       </a:pPr>
                       <a:r>
-                        <a:t>2021 · Referencia</a:t>
+                        <a:t>HistGradientBoosting</a:t>
                       </a:r>
                     </a:p>
                   </a:txBody>
@@ -5931,7 +5931,7 @@
                         </a:defRPr>
                       </a:pPr>
                       <a:r>
-                        <a:t>1,490</a:t>
+                        <a:t>6.84</a:t>
                       </a:r>
                     </a:p>
                   </a:txBody>
@@ -5955,7 +5955,7 @@
                         </a:defRPr>
                       </a:pPr>
                       <a:r>
-                        <a:t>12.12</a:t>
+                        <a:t>4.67</a:t>
                       </a:r>
                     </a:p>
                   </a:txBody>
@@ -5979,7 +5979,7 @@
                         </a:defRPr>
                       </a:pPr>
                       <a:r>
-                        <a:t>8.05</a:t>
+                        <a:t>20.0/50</a:t>
                       </a:r>
                     </a:p>
                   </a:txBody>
@@ -6003,7 +6003,7 @@
                         </a:defRPr>
                       </a:pPr>
                       <a:r>
-                        <a:t>16/50</a:t>
+                        <a:t>199.6</a:t>
                       </a:r>
                     </a:p>
                   </a:txBody>
@@ -6029,7 +6029,7 @@
                         </a:defRPr>
                       </a:pPr>
                       <a:r>
-                        <a:t>2021 · Ridge</a:t>
+                        <a:t>LightGBM</a:t>
                       </a:r>
                     </a:p>
                   </a:txBody>
@@ -6053,7 +6053,7 @@
                         </a:defRPr>
                       </a:pPr>
                       <a:r>
-                        <a:t>1,490</a:t>
+                        <a:t>6.83</a:t>
                       </a:r>
                     </a:p>
                   </a:txBody>
@@ -6077,7 +6077,7 @@
                         </a:defRPr>
                       </a:pPr>
                       <a:r>
-                        <a:t>9.21</a:t>
+                        <a:t>4.84</a:t>
                       </a:r>
                     </a:p>
                   </a:txBody>
@@ -6101,7 +6101,7 @@
                         </a:defRPr>
                       </a:pPr>
                       <a:r>
-                        <a:t>5.49</a:t>
+                        <a:t>21.0/50</a:t>
                       </a:r>
                     </a:p>
                   </a:txBody>
@@ -6125,7 +6125,7 @@
                         </a:defRPr>
                       </a:pPr>
                       <a:r>
-                        <a:t>19/50</a:t>
+                        <a:t>126.6</a:t>
                       </a:r>
                     </a:p>
                   </a:txBody>
@@ -6151,7 +6151,7 @@
                         </a:defRPr>
                       </a:pPr>
                       <a:r>
-                        <a:t>2024 · Referencia</a:t>
+                        <a:t>CatBoost</a:t>
                       </a:r>
                     </a:p>
                   </a:txBody>
@@ -6175,7 +6175,7 @@
                         </a:defRPr>
                       </a:pPr>
                       <a:r>
-                        <a:t>1,476</a:t>
+                        <a:t>6.91</a:t>
                       </a:r>
                     </a:p>
                   </a:txBody>
@@ -6199,7 +6199,7 @@
                         </a:defRPr>
                       </a:pPr>
                       <a:r>
-                        <a:t>5.64</a:t>
+                        <a:t>4.67</a:t>
                       </a:r>
                     </a:p>
                   </a:txBody>
@@ -6223,7 +6223,7 @@
                         </a:defRPr>
                       </a:pPr>
                       <a:r>
-                        <a:t>3.54</a:t>
+                        <a:t>20.5/50</a:t>
                       </a:r>
                     </a:p>
                   </a:txBody>
@@ -6247,7 +6247,7 @@
                         </a:defRPr>
                       </a:pPr>
                       <a:r>
-                        <a:t>27/50</a:t>
+                        <a:t>1045.2</a:t>
                       </a:r>
                     </a:p>
                   </a:txBody>
@@ -6273,7 +6273,7 @@
                         </a:defRPr>
                       </a:pPr>
                       <a:r>
-                        <a:t>2024 · Ridge</a:t>
+                        <a:t>Ridge</a:t>
                       </a:r>
                     </a:p>
                   </a:txBody>
@@ -6297,7 +6297,7 @@
                         </a:defRPr>
                       </a:pPr>
                       <a:r>
-                        <a:t>1,476</a:t>
+                        <a:t>9.01</a:t>
                       </a:r>
                     </a:p>
                   </a:txBody>
@@ -6321,7 +6321,7 @@
                         </a:defRPr>
                       </a:pPr>
                       <a:r>
-                        <a:t>8.58</a:t>
+                        <a:t>5.22</a:t>
                       </a:r>
                     </a:p>
                   </a:txBody>
@@ -6345,7 +6345,7 @@
                         </a:defRPr>
                       </a:pPr>
                       <a:r>
-                        <a:t>4.49</a:t>
+                        <a:t>20.0/50</a:t>
                       </a:r>
                     </a:p>
                   </a:txBody>
@@ -6369,7 +6369,7 @@
                         </a:defRPr>
                       </a:pPr>
                       <a:r>
-                        <a:t>27/50</a:t>
+                        <a:t>12.8</a:t>
                       </a:r>
                     </a:p>
                   </a:txBody>
@@ -6413,7 +6413,7 @@
                 </a:solidFill>
                 <a:latin typeface="Segoe UI"/>
               </a:rPr>
-              <a:t>La evidencia no demuestra superioridad consistente.</a:t>
+              <a:t>MAE medio 24.1% menor que Ridge.</a:t>
             </a:r>
           </a:p>
         </p:txBody>
@@ -6447,7 +6447,7 @@
                 </a:solidFill>
                 <a:latin typeface="Segoe UI"/>
               </a:rPr>
-              <a:t>Spearman referencia / Ridge: 0.485 / 0.599 en 2021 y 0.827 / 0.811 en 2024. Análisis posterior, sin reajuste del modelo.</a:t>
+              <a:t>Empate de MAE con tolerancia 0.05 pp; gana por error ponderado. Ridge es el más rápido. Selección retrospectiva.</a:t>
             </a:r>
           </a:p>
         </p:txBody>
@@ -6461,7 +6461,7 @@
         <p:spPr>
           <a:xfrm>
             <a:off x="594360" y="6245352"/>
-            <a:ext cx="10881360" cy="411480"/>
+            <a:ext cx="10881360" cy="228092"/>
           </a:xfrm>
           <a:prstGeom prst="rect">
             <a:avLst/>
@@ -6481,7 +6481,7 @@
                 </a:solidFill>
                 <a:latin typeface="Segoe UI"/>
               </a:rPr>
-              <a:t>MAE en puntos porcentuales. Ponderación por SV+NV observado del objetivo. Top50 dentro de cada cohorte evaluable.</a:t>
+              <a:t>Media de 2021/2024 con igual peso por elección. Referencia adicional: MAE 8.88 pp. No valida 2027.</a:t>
             </a:r>
           </a:p>
         </p:txBody>
@@ -6521,7 +6521,7 @@
         <p:spPr>
           <a:xfrm>
             <a:off x="594360" y="320040"/>
-            <a:ext cx="10972800" cy="274320"/>
+            <a:ext cx="10972800" cy="259080"/>
           </a:xfrm>
           <a:prstGeom prst="rect">
             <a:avLst/>
@@ -6555,7 +6555,7 @@
         <p:spPr>
           <a:xfrm>
             <a:off x="594360" y="822960"/>
-            <a:ext cx="10972800" cy="1097280"/>
+            <a:ext cx="10972800" cy="568960"/>
           </a:xfrm>
           <a:prstGeom prst="rect">
             <a:avLst/>
@@ -6589,7 +6589,7 @@
         <p:spPr>
           <a:xfrm>
             <a:off x="594360" y="1965960"/>
-            <a:ext cx="10881360" cy="914400"/>
+            <a:ext cx="10881360" cy="460502"/>
           </a:xfrm>
           <a:prstGeom prst="rect">
             <a:avLst/>
@@ -6623,7 +6623,7 @@
         <p:spPr>
           <a:xfrm>
             <a:off x="594360" y="2554478"/>
-            <a:ext cx="10881360" cy="914400"/>
+            <a:ext cx="10881360" cy="692912"/>
           </a:xfrm>
           <a:prstGeom prst="rect">
             <a:avLst/>
@@ -6691,7 +6691,7 @@
         <p:spPr>
           <a:xfrm>
             <a:off x="594360" y="4552696"/>
-            <a:ext cx="10881360" cy="914400"/>
+            <a:ext cx="10881360" cy="692912"/>
           </a:xfrm>
           <a:prstGeom prst="rect">
             <a:avLst/>
@@ -6725,7 +6725,7 @@
         <p:spPr>
           <a:xfrm>
             <a:off x="594360" y="6245352"/>
-            <a:ext cx="10881360" cy="411480"/>
+            <a:ext cx="10881360" cy="228092"/>
           </a:xfrm>
           <a:prstGeom prst="rect">
             <a:avLst/>
@@ -6785,7 +6785,7 @@
         <p:spPr>
           <a:xfrm>
             <a:off x="594360" y="320040"/>
-            <a:ext cx="10972800" cy="274320"/>
+            <a:ext cx="10972800" cy="259080"/>
           </a:xfrm>
           <a:prstGeom prst="rect">
             <a:avLst/>
@@ -6819,7 +6819,7 @@
         <p:spPr>
           <a:xfrm>
             <a:off x="594360" y="822960"/>
-            <a:ext cx="10972800" cy="1097280"/>
+            <a:ext cx="10972800" cy="568960"/>
           </a:xfrm>
           <a:prstGeom prst="rect">
             <a:avLst/>
@@ -6839,7 +6839,7 @@
                 </a:solidFill>
                 <a:latin typeface="Segoe UI"/>
               </a:rPr>
-              <a:t>Una ficha para revisar cada prioridad</a:t>
+              <a:t>Una ficha para entender la selección</a:t>
             </a:r>
           </a:p>
         </p:txBody>
@@ -6853,7 +6853,7 @@
         <p:spPr>
           <a:xfrm>
             <a:off x="594360" y="1965960"/>
-            <a:ext cx="10881360" cy="914400"/>
+            <a:ext cx="10881360" cy="460502"/>
           </a:xfrm>
           <a:prstGeom prst="rect">
             <a:avLst/>
@@ -6867,13 +6867,13 @@
           <a:lstStyle/>
           <a:p>
             <a:r>
-              <a:rPr sz="2600" b="1">
+              <a:rPr sz="2500" b="1">
                 <a:solidFill>
                   <a:srgbClr val="10685F"/>
                 </a:solidFill>
                 <a:latin typeface="Segoe UI"/>
               </a:rPr>
-              <a:t>¿Por qué este municipio?</a:t>
+              <a:t>Resultados observados y proyección diferenciados</a:t>
             </a:r>
           </a:p>
         </p:txBody>
@@ -6886,8 +6886,8 @@
         </p:nvSpPr>
         <p:spPr>
           <a:xfrm>
-            <a:off x="594360" y="2569972"/>
-            <a:ext cx="10881360" cy="914400"/>
+            <a:off x="594360" y="2554478"/>
+            <a:ext cx="10881360" cy="723900"/>
           </a:xfrm>
           <a:prstGeom prst="rect">
             <a:avLst/>
@@ -6907,7 +6907,7 @@
                 </a:solidFill>
                 <a:latin typeface="Segoe UI"/>
               </a:rPr>
-              <a:t>Puesto, antecedentes, calidad NS y acuerdo entre referencia y Ridge. Perfil CCPC por grupos como capa descriptiva separada.</a:t>
+              <a:t>Serie temporal 2009–2024 con 2027 separado visualmente. Faltantes visibles y cobertura declarada.</a:t>
             </a:r>
           </a:p>
         </p:txBody>
@@ -6920,8 +6920,8 @@
         </p:nvSpPr>
         <p:spPr>
           <a:xfrm>
-            <a:off x="594360" y="3421888"/>
-            <a:ext cx="10881360" cy="914400"/>
+            <a:off x="594360" y="3406394"/>
+            <a:ext cx="10881360" cy="723900"/>
           </a:xfrm>
           <a:prstGeom prst="rect">
             <a:avLst/>
@@ -6935,13 +6935,13 @@
           <a:lstStyle/>
           <a:p>
             <a:r>
-              <a:rPr sz="2200" b="0">
+              <a:rPr sz="2100" b="0">
                 <a:solidFill>
                   <a:srgbClr val="15353B"/>
                 </a:solidFill>
                 <a:latin typeface="Segoe UI"/>
               </a:rPr>
-              <a:t>Frecuencia entre seis variantes: dos métodos × NS 5/10/20. N equivale a municipios atendidos del plan actual.</a:t>
+              <a:t>Brecha municipal frente al estado con el mismo método y denominador. Las diferencias agregadas no identifican causas.</a:t>
             </a:r>
           </a:p>
         </p:txBody>
@@ -6954,8 +6954,8 @@
         </p:nvSpPr>
         <p:spPr>
           <a:xfrm>
-            <a:off x="594360" y="4304792"/>
-            <a:ext cx="10881360" cy="914400"/>
+            <a:off x="594360" y="4258310"/>
+            <a:ext cx="10881360" cy="723900"/>
           </a:xfrm>
           <a:prstGeom prst="rect">
             <a:avLst/>
@@ -6975,7 +6975,7 @@
                 </a:solidFill>
                 <a:latin typeface="Segoe UI"/>
               </a:rPr>
-              <a:t>Compara rankings con N equivalente. No recalcula presupuesto ni reparto y no es probabilidad. El caso 23008 documenta por separado el ranking de referencia top50.</a:t>
+              <a:t>Métricas reales y coeficientes Ridge disponibles. Los coeficientes no son efectos causales ni explicaciones individuales.</a:t>
             </a:r>
           </a:p>
         </p:txBody>
@@ -6989,7 +6989,7 @@
         <p:spPr>
           <a:xfrm>
             <a:off x="594360" y="6245352"/>
-            <a:ext cx="10881360" cy="411480"/>
+            <a:ext cx="10881360" cy="228092"/>
           </a:xfrm>
           <a:prstGeom prst="rect">
             <a:avLst/>
@@ -7009,7 +7009,7 @@
                 </a:solidFill>
                 <a:latin typeface="Segoe UI"/>
               </a:rPr>
-              <a:t>Frecuencia descriptiva. Las variantes comparten datos y pueden equivocarse juntas.</a:t>
+              <a:t>Demo6. Umbrales nacionales por año y método; fijos entre escenarios.</a:t>
             </a:r>
           </a:p>
         </p:txBody>
@@ -7049,7 +7049,7 @@
         <p:spPr>
           <a:xfrm>
             <a:off x="594360" y="320040"/>
-            <a:ext cx="10972800" cy="274320"/>
+            <a:ext cx="10972800" cy="259080"/>
           </a:xfrm>
           <a:prstGeom prst="rect">
             <a:avLst/>
@@ -7083,7 +7083,7 @@
         <p:spPr>
           <a:xfrm>
             <a:off x="594360" y="822960"/>
-            <a:ext cx="10972800" cy="1097280"/>
+            <a:ext cx="10972800" cy="568960"/>
           </a:xfrm>
           <a:prstGeom prst="rect">
             <a:avLst/>
@@ -7117,7 +7117,7 @@
         <p:spPr>
           <a:xfrm>
             <a:off x="594360" y="1965960"/>
-            <a:ext cx="10881360" cy="914400"/>
+            <a:ext cx="10881360" cy="445008"/>
           </a:xfrm>
           <a:prstGeom prst="rect">
             <a:avLst/>
@@ -7151,7 +7151,7 @@
         <p:spPr>
           <a:xfrm>
             <a:off x="594360" y="2538984"/>
-            <a:ext cx="10881360" cy="914400"/>
+            <a:ext cx="10881360" cy="723900"/>
           </a:xfrm>
           <a:prstGeom prst="rect">
             <a:avLst/>
@@ -7165,13 +7165,13 @@
           <a:lstStyle/>
           <a:p>
             <a:r>
-              <a:rPr sz="2000" b="0">
+              <a:rPr sz="2100" b="0">
                 <a:solidFill>
                   <a:srgbClr val="15353B"/>
                 </a:solidFill>
                 <a:latin typeface="Segoe UI"/>
               </a:rPr>
-              <a:t>Puesto Ridge 1, referencia 3. Base 62.106806%. Estabilidad 4/6 del ranking de referencia top50. NS 2021: 9.60%, excluye umbral ≤5%.</a:t>
+              <a:t>HistGradientBoosting, puesto 9; referencia 3. Base 61.636222%. Frecuencia nacional top50 4/6.</a:t>
             </a:r>
           </a:p>
         </p:txBody>
@@ -7184,8 +7184,8 @@
         </p:nvSpPr>
         <p:spPr>
           <a:xfrm>
-            <a:off x="594360" y="3359912"/>
-            <a:ext cx="10881360" cy="914400"/>
+            <a:off x="594360" y="3390900"/>
+            <a:ext cx="10881360" cy="754888"/>
           </a:xfrm>
           <a:prstGeom prst="rect">
             <a:avLst/>
@@ -7199,13 +7199,13 @@
           <a:lstStyle/>
           <a:p>
             <a:r>
-              <a:rPr sz="2300" b="0">
+              <a:rPr sz="2200" b="0">
                 <a:solidFill>
                   <a:srgbClr val="15353B"/>
                 </a:solidFill>
                 <a:latin typeface="Segoe UI"/>
               </a:rPr>
-              <a:t>1,000 personas distintas previstas para SMS Suecia: 3 votos adicionales hipotéticos, rango externo 1.3–4.8.</a:t>
+              <a:t>1,000 personas asignadas a SMS Suecia: 3 votos adicionales hipotéticos; rango externo 1.3–4.8.</a:t>
             </a:r>
           </a:p>
         </p:txBody>
@@ -7219,7 +7219,7 @@
         <p:spPr>
           <a:xfrm>
             <a:off x="594360" y="4273804"/>
-            <a:ext cx="10881360" cy="914400"/>
+            <a:ext cx="10881360" cy="398526"/>
           </a:xfrm>
           <a:prstGeom prst="rect">
             <a:avLst/>
@@ -7239,7 +7239,7 @@
                 </a:solidFill>
                 <a:latin typeface="Segoe UI"/>
               </a:rPr>
-              <a:t>Escenario 62.105631%. Reducción de 0.001175 pp. El efecto publicado proviene de Suecia y su traslado a México requiere evaluación.</a:t>
+              <a:t>Posterior 61.635048%. Reducción 0.001175 pp. Traslado a México sujeto a evaluación.</a:t>
             </a:r>
           </a:p>
         </p:txBody>
@@ -7253,7 +7253,7 @@
         <p:spPr>
           <a:xfrm>
             <a:off x="594360" y="6245352"/>
-            <a:ext cx="10881360" cy="411480"/>
+            <a:ext cx="10881360" cy="228092"/>
           </a:xfrm>
           <a:prstGeom prst="rect">
             <a:avLst/>
@@ -7273,7 +7273,7 @@
                 </a:solidFill>
                 <a:latin typeface="Segoe UI"/>
               </a:rPr>
-              <a:t>Fuente: entrega/caso_municipal.json. SV+NV 2024: 255,362. SMS: Lindgren, Nyman y Oskarsson (2025), DOI 10.1017/S0007123424000504.</a:t>
+              <a:t>Fuente: entrega/caso_municipal.json. Modelo seleccionado del benchmark. SV+NV 2024: 255,362. DOI 10.1017/S0007123424000504.</a:t>
             </a:r>
           </a:p>
         </p:txBody>
@@ -7313,7 +7313,7 @@
         <p:spPr>
           <a:xfrm>
             <a:off x="594360" y="320040"/>
-            <a:ext cx="10972800" cy="274320"/>
+            <a:ext cx="10972800" cy="259080"/>
           </a:xfrm>
           <a:prstGeom prst="rect">
             <a:avLst/>
@@ -7347,7 +7347,7 @@
         <p:spPr>
           <a:xfrm>
             <a:off x="594360" y="822960"/>
-            <a:ext cx="10972800" cy="1097280"/>
+            <a:ext cx="10972800" cy="568960"/>
           </a:xfrm>
           <a:prstGeom prst="rect">
             <a:avLst/>
@@ -7381,7 +7381,7 @@
         <p:spPr>
           <a:xfrm>
             <a:off x="594360" y="1965960"/>
-            <a:ext cx="10881360" cy="914400"/>
+            <a:ext cx="10881360" cy="460502"/>
           </a:xfrm>
           <a:prstGeom prst="rect">
             <a:avLst/>
@@ -7415,7 +7415,7 @@
         <p:spPr>
           <a:xfrm>
             <a:off x="594360" y="2554478"/>
-            <a:ext cx="10881360" cy="914400"/>
+            <a:ext cx="10881360" cy="723900"/>
           </a:xfrm>
           <a:prstGeom prst="rect">
             <a:avLst/>
@@ -7449,7 +7449,7 @@
         <p:spPr>
           <a:xfrm>
             <a:off x="594360" y="3406394"/>
-            <a:ext cx="10881360" cy="914400"/>
+            <a:ext cx="10881360" cy="723900"/>
           </a:xfrm>
           <a:prstGeom prst="rect">
             <a:avLst/>
@@ -7483,7 +7483,7 @@
         <p:spPr>
           <a:xfrm>
             <a:off x="594360" y="4258310"/>
-            <a:ext cx="10881360" cy="914400"/>
+            <a:ext cx="10881360" cy="723900"/>
           </a:xfrm>
           <a:prstGeom prst="rect">
             <a:avLst/>
@@ -7517,7 +7517,7 @@
         <p:spPr>
           <a:xfrm>
             <a:off x="594360" y="6245352"/>
-            <a:ext cx="10881360" cy="411480"/>
+            <a:ext cx="10881360" cy="228092"/>
           </a:xfrm>
           <a:prstGeom prst="rect">
             <a:avLst/>

</xml_diff>

<commit_message>
Mejoras segun gpt astra JAJA
</commit_message>
<xml_diff>
--- a/02_Prediccion_y_escenarios_de_riesgo/entrega/presentacion/Umbral_presentacion.pptx
+++ b/02_Prediccion_y_escenarios_de_riesgo/entrega/presentacion/Umbral_presentacion.pptx
@@ -681,7 +681,7 @@
           </a:p>
           <a:p>
             <a:r>
-              <a:t>Guía: demo/DEMO6.md. Cartografía municipal y complemento insular INEGI 2025. Fuentes primarias: https://ine.mx/transparencia/datos-abiertos/visualizacion-datos/conteos-censales-participacion/ Convocatoria: https://ine.mx/wp-content/uploads/2026/09/Convocatoria_Hackaton-1.pdf</a:t>
+              <a:t>Guía: demo/DEMO7.md. Cartografía municipal y complemento insular INEGI 2025. Fuentes primarias: https://ine.mx/transparencia/datos-abiertos/visualizacion-datos/conteos-censales-participacion/ Convocatoria: https://ine.mx/wp-content/uploads/2026/09/Convocatoria_Hackaton-1.pdf</a:t>
             </a:r>
           </a:p>
         </p:txBody>
@@ -1081,7 +1081,7 @@
           </a:p>
           <a:p>
             <a:r>
-              <a:t>Demo6. Umbrales nacionales por año y método; fijos entre escenarios. Fuentes primarias: https://ine.mx/transparencia/datos-abiertos/visualizacion-datos/conteos-censales-participacion/ Convocatoria: https://ine.mx/wp-content/uploads/2026/09/Convocatoria_Hackaton-1.pdf</a:t>
+              <a:t>Demo7 y docs/PLANES_ACCION_ESTATALES_PARTICIPACION.md, sección 8. Propuestas por validar con el área usuaria. Fuentes primarias: https://ine.mx/transparencia/datos-abiertos/visualizacion-datos/conteos-censales-participacion/ Convocatoria: https://ine.mx/wp-content/uploads/2026/09/Convocatoria_Hackaton-1.pdf</a:t>
             </a:r>
           </a:p>
         </p:txBody>
@@ -4488,7 +4488,7 @@
                 </a:solidFill>
                 <a:latin typeface="Segoe UI"/>
               </a:rPr>
-              <a:t>Versión técnica · 16 de octubre de 2026</a:t>
+              <a:t>Versión técnica · 21 de octubre de 2026</a:t>
             </a:r>
           </a:p>
         </p:txBody>
@@ -4786,7 +4786,7 @@
                 </a:solidFill>
                 <a:latin typeface="Segoe UI"/>
               </a:rPr>
-              <a:t>Equipo: aguas.exe. Firmas, registro y envío formal siguen pendientes.</a:t>
+              <a:t>Equipo: aguas.exe. Registro, elegibilidad, firmas y envío formal no acreditados.</a:t>
             </a:r>
           </a:p>
         </p:txBody>
@@ -4914,7 +4914,7 @@
                 </a:solidFill>
                 <a:latin typeface="Segoe UI"/>
               </a:rPr>
-              <a:t>Consulta territorial en demo6</a:t>
+              <a:t>Consulta territorial en demo7</a:t>
             </a:r>
           </a:p>
         </p:txBody>
@@ -5084,7 +5084,7 @@
                 </a:solidFill>
                 <a:latin typeface="Segoe UI"/>
               </a:rPr>
-              <a:t>Guía: demo/DEMO6.md. Cartografía municipal y complemento insular INEGI 2025.</a:t>
+              <a:t>Guía: demo/DEMO7.md. Cartografía municipal y complemento insular INEGI 2025.</a:t>
             </a:r>
           </a:p>
         </p:txBody>
@@ -6839,7 +6839,7 @@
                 </a:solidFill>
                 <a:latin typeface="Segoe UI"/>
               </a:rPr>
-              <a:t>Una ficha para entender la selección</a:t>
+              <a:t>Plan estatal y semáforo en demo7</a:t>
             </a:r>
           </a:p>
         </p:txBody>
@@ -6873,7 +6873,7 @@
                 </a:solidFill>
                 <a:latin typeface="Segoe UI"/>
               </a:rPr>
-              <a:t>Resultados observados y proyección diferenciados</a:t>
+              <a:t>Escenario hipotético editable</a:t>
             </a:r>
           </a:p>
         </p:txBody>
@@ -6907,7 +6907,7 @@
                 </a:solidFill>
                 <a:latin typeface="Segoe UI"/>
               </a:rPr>
-              <a:t>Serie temporal 2009–2024 con 2027 separado visualmente. Faltantes visibles y cobertura declarada.</a:t>
+              <a:t>Cobertura inicial del 10%; efecto supuesto de 1.5 pp entre alcanzados. Variantes de 0.3 y 3 pp. No es eficacia medida del plan.</a:t>
             </a:r>
           </a:p>
         </p:txBody>
@@ -6941,7 +6941,7 @@
                 </a:solidFill>
                 <a:latin typeface="Segoe UI"/>
               </a:rPr>
-              <a:t>Brecha municipal frente al estado con el mismo método y denominador. Las diferencias agregadas no identifican causas.</a:t>
+              <a:t>Mapas sin/con acción con cortes nacionales fijos por tercios: bajo, medio y alto. Gris significa sin estimación; nunca cero.</a:t>
             </a:r>
           </a:p>
         </p:txBody>
@@ -6975,7 +6975,7 @@
                 </a:solidFill>
                 <a:latin typeface="Segoe UI"/>
               </a:rPr>
-              <a:t>Métricas reales y coeficientes Ridge disponibles. Los coeficientes no son efectos causales ni explicaciones individuales.</a:t>
+              <a:t>Distribución proporcional; CSV con tasas antes/después, semáforo, cobertura, método y fuentes. La vista de diferencias muestra cambios pequeños.</a:t>
             </a:r>
           </a:p>
         </p:txBody>
@@ -7009,7 +7009,7 @@
                 </a:solidFill>
                 <a:latin typeface="Segoe UI"/>
               </a:rPr>
-              <a:t>Demo6. Umbrales nacionales por año y método; fijos entre escenarios.</a:t>
+              <a:t>Demo7 y docs/PLANES_ACCION_ESTATALES_PARTICIPACION.md, sección 8. Propuestas por validar con el área usuaria.</a:t>
             </a:r>
           </a:p>
         </p:txBody>
@@ -7435,7 +7435,7 @@
                 </a:solidFill>
                 <a:latin typeface="Segoe UI"/>
               </a:rPr>
-              <a:t>Exportar territorio, acción y cita, cobertura total, distribución, supuestos y estabilidad del plan actual.</a:t>
+              <a:t>Definir prioridad y cobertura; exportar territorio, acción, fuente, distribución y supuestos. Revisar la estabilidad por separado.</a:t>
             </a:r>
           </a:p>
         </p:txBody>

</xml_diff>